<commit_message>
docs: update presentation slide 10 (Content & Licensing) with v1.1 doc changes
- Bilingual catalog: Spanish + English public-domain (in dev) on one line
- Corrected author royalty: 45% → 36% (45% was Noetia's share, not the author's)
- Publisher timeline precision: first conversations Q3 2026, no agreements signed
- Hardware DRM roadmap: Widevine + FairPlay named as Q1 2027 pre-condition for publisher deals
- Soft DRM specifics: AES-256 at rest, presigned URLs 5-min TTL, account binding

Co-Authored-By: Claude Sonnet 4.6 <noreply@anthropic.com>
</commit_message>
<xml_diff>
--- a/docs/Noetia_Presentation.pptx
+++ b/docs/Noetia_Presentation.pptx
@@ -3293,7 +3293,7 @@
           <a:lstStyle/>
           <a:p>
             <a:r>
-              <a:rPr lang="en-US" dirty="0" sz="4000" b="1">
+              <a:rPr lang="en-US" dirty="0" sz="2800" b="1">
                 <a:solidFill>
                   <a:srgbClr val="FFFFFF"/>
                 </a:solidFill>
@@ -3319,62 +3319,62 @@
           <a:lstStyle/>
           <a:p>
             <a:r>
-              <a:rPr lang="en-US" dirty="0" sz="2200">
-                <a:solidFill>
-                  <a:srgbClr val="FFFFFF"/>
-                </a:solidFill>
-              </a:rPr>
-              <a:t>Public domain (38+ Spanish titles): Gutenberg + LibriVox CC0 — zero cost</a:t>
-            </a:r>
-          </a:p>
-          <a:p>
-            <a:r>
-              <a:rPr lang="en-US" dirty="0" sz="2200">
-                <a:solidFill>
-                  <a:srgbClr val="FFFFFF"/>
-                </a:solidFill>
-              </a:rPr>
-              <a:t>English public-domain catalog in active development for Q3 2026</a:t>
-            </a:r>
-          </a:p>
-          <a:p>
-            <a:r>
-              <a:rPr lang="en-US" dirty="0" sz="2200">
-                <a:solidFill>
-                  <a:srgbClr val="FFFFFF"/>
-                </a:solidFill>
-              </a:rPr>
-              <a:t>Author-direct model: non-exclusive license, 45% royalty, 30-day withdrawal</a:t>
-            </a:r>
-          </a:p>
-          <a:p>
-            <a:r>
-              <a:rPr lang="en-US" dirty="0" sz="2200">
-                <a:solidFill>
-                  <a:srgbClr val="FFFFFF"/>
-                </a:solidFill>
-              </a:rPr>
-              <a:t>Publisher pipeline: active outreach, first deals targeted Q4 2026</a:t>
-            </a:r>
-          </a:p>
-          <a:p>
-            <a:r>
-              <a:rPr lang="en-US" dirty="0" sz="2200">
-                <a:solidFill>
-                  <a:srgbClr val="FFFFFF"/>
-                </a:solidFill>
-              </a:rPr>
-              <a:t>DRM: soft DRM (account binding + AES-256 encryption + signed URLs)</a:t>
-            </a:r>
-          </a:p>
-          <a:p>
-            <a:r>
-              <a:rPr lang="en-US" dirty="0" sz="2200">
-                <a:solidFill>
-                  <a:srgbClr val="FFFFFF"/>
-                </a:solidFill>
-              </a:rPr>
-              <a:t>Territory: worldwide by default; per-territory negotiation for publisher deals</a:t>
+              <a:rPr lang="en-US" dirty="0" sz="1800" b="0">
+                <a:solidFill>
+                  <a:srgbClr val="E0E0E0"/>
+                </a:solidFill>
+              </a:rPr>
+              <a:t>38+ Spanish public-domain + English catalog in dev — Gutenberg / LibriVox CC0, zero cost</a:t>
+            </a:r>
+          </a:p>
+          <a:p>
+            <a:r>
+              <a:rPr lang="en-US" dirty="0" sz="1800" b="0">
+                <a:solidFill>
+                  <a:srgbClr val="E0E0E0"/>
+                </a:solidFill>
+              </a:rPr>
+              <a:t>Author-direct: non-exclusive license, 36% author royalty, 30-day withdrawal right</a:t>
+            </a:r>
+          </a:p>
+          <a:p>
+            <a:r>
+              <a:rPr lang="en-US" dirty="0" sz="1800" b="0">
+                <a:solidFill>
+                  <a:srgbClr val="E0E0E0"/>
+                </a:solidFill>
+              </a:rPr>
+              <a:t>Publisher pipeline: first conversations Q3 2026 — no agreements signed</a:t>
+            </a:r>
+          </a:p>
+          <a:p>
+            <a:r>
+              <a:rPr lang="en-US" dirty="0" sz="1800" b="0">
+                <a:solidFill>
+                  <a:srgbClr val="E0E0E0"/>
+                </a:solidFill>
+              </a:rPr>
+              <a:t>Publisher activation requires hardware DRM (Widevine + FairPlay) — Q1 2027 target</a:t>
+            </a:r>
+          </a:p>
+          <a:p>
+            <a:r>
+              <a:rPr lang="en-US" dirty="0" sz="1800" b="0">
+                <a:solidFill>
+                  <a:srgbClr val="E0E0E0"/>
+                </a:solidFill>
+              </a:rPr>
+              <a:t>Soft DRM today: AES-256 at rest  ·  presigned URLs (5-min TTL)  ·  account binding</a:t>
+            </a:r>
+          </a:p>
+          <a:p>
+            <a:r>
+              <a:rPr lang="en-US" dirty="0" sz="1800" b="0">
+                <a:solidFill>
+                  <a:srgbClr val="E0E0E0"/>
+                </a:solidFill>
+              </a:rPr>
+              <a:t>Territory: worldwide by default; per-territory access controls before publisher activation</a:t>
             </a:r>
           </a:p>
         </p:txBody>

</xml_diff>

<commit_message>
docs: remove bullet points from title and closing slides (1 + 13)
Suppress inherited placeholder list style with <a:buNone/> and center-align
text on slides 1 and 13 — clean title-card layout, no bullet markers.

Co-Authored-By: Claude Sonnet 4.6 <noreply@anthropic.com>
</commit_message>
<xml_diff>
--- a/docs/Noetia_Presentation.pptx
+++ b/docs/Noetia_Presentation.pptx
@@ -3187,6 +3187,9 @@
           <a:bodyPr/>
           <a:lstStyle/>
           <a:p>
+            <a:pPr algn="ctr">
+              <a:buNone/>
+            </a:pPr>
             <a:r>
               <a:rPr lang="en-US" dirty="0" sz="3200" b="1">
                 <a:solidFill>
@@ -3197,6 +3200,9 @@
             </a:r>
           </a:p>
           <a:p>
+            <a:pPr algn="ctr">
+              <a:buNone/>
+            </a:pPr>
             <a:r>
               <a:rPr lang="en-US" dirty="0" sz="3200" b="1">
                 <a:solidFill>
@@ -3831,6 +3837,9 @@
           <a:bodyPr/>
           <a:lstStyle/>
           <a:p>
+            <a:pPr algn="ctr">
+              <a:buNone/>
+            </a:pPr>
             <a:r>
               <a:rPr lang="en-US" dirty="0" sz="3200" b="1">
                 <a:solidFill>
@@ -3841,6 +3850,9 @@
             </a:r>
           </a:p>
           <a:p>
+            <a:pPr algn="ctr">
+              <a:buNone/>
+            </a:pPr>
             <a:r>
               <a:rPr lang="en-US" dirty="0" sz="3200" b="1">
                 <a:solidFill>
@@ -3851,6 +3863,9 @@
             </a:r>
           </a:p>
           <a:p>
+            <a:pPr algn="ctr">
+              <a:buNone/>
+            </a:pPr>
             <a:r>
               <a:rPr lang="en-US" dirty="0" sz="3200" b="1">
                 <a:solidFill>

</xml_diff>

<commit_message>
docs: reduce font size on slides 9 and 12 to eliminate line wrapping
22pt → 16pt on Business Model and Growth Strategy body text — all 6 lines
now fit on single rows without wrapping.

Co-Authored-By: Claude Sonnet 4.6 <noreply@anthropic.com>
</commit_message>
<xml_diff>
--- a/docs/Noetia_Presentation.pptx
+++ b/docs/Noetia_Presentation.pptx
@@ -3667,7 +3667,7 @@
           <a:lstStyle/>
           <a:p>
             <a:r>
-              <a:rPr lang="en-US" dirty="0" sz="2200">
+              <a:rPr lang="en-US" dirty="0" sz="1600">
                 <a:solidFill>
                   <a:srgbClr val="FFFFFF"/>
                 </a:solidFill>
@@ -3677,7 +3677,7 @@
           </a:p>
           <a:p>
             <a:r>
-              <a:rPr lang="en-US" dirty="0" sz="2200">
+              <a:rPr lang="en-US" dirty="0" sz="1600">
                 <a:solidFill>
                   <a:srgbClr val="FFFFFF"/>
                 </a:solidFill>
@@ -3687,7 +3687,7 @@
           </a:p>
           <a:p>
             <a:r>
-              <a:rPr lang="en-US" dirty="0" sz="2200">
+              <a:rPr lang="en-US" dirty="0" sz="1600">
                 <a:solidFill>
                   <a:srgbClr val="FFFFFF"/>
                 </a:solidFill>
@@ -3697,7 +3697,7 @@
           </a:p>
           <a:p>
             <a:r>
-              <a:rPr lang="en-US" dirty="0" sz="2200">
+              <a:rPr lang="en-US" dirty="0" sz="1600">
                 <a:solidFill>
                   <a:srgbClr val="FFFFFF"/>
                 </a:solidFill>
@@ -3707,7 +3707,7 @@
           </a:p>
           <a:p>
             <a:r>
-              <a:rPr lang="en-US" dirty="0" sz="2200">
+              <a:rPr lang="en-US" dirty="0" sz="1600">
                 <a:solidFill>
                   <a:srgbClr val="FFFFFF"/>
                 </a:solidFill>
@@ -3717,7 +3717,7 @@
           </a:p>
           <a:p>
             <a:r>
-              <a:rPr lang="en-US" dirty="0" sz="2200">
+              <a:rPr lang="en-US" dirty="0" sz="1600">
                 <a:solidFill>
                   <a:srgbClr val="FFFFFF"/>
                 </a:solidFill>
@@ -5125,7 +5125,7 @@
           <a:lstStyle/>
           <a:p>
             <a:r>
-              <a:rPr lang="en-US" dirty="0" sz="2200">
+              <a:rPr lang="en-US" dirty="0" sz="1600">
                 <a:solidFill>
                   <a:srgbClr val="FFFFFF"/>
                 </a:solidFill>
@@ -5135,7 +5135,7 @@
           </a:p>
           <a:p>
             <a:r>
-              <a:rPr lang="en-US" dirty="0" sz="2200">
+              <a:rPr lang="en-US" dirty="0" sz="1600">
                 <a:solidFill>
                   <a:srgbClr val="FFFFFF"/>
                 </a:solidFill>
@@ -5145,7 +5145,7 @@
           </a:p>
           <a:p>
             <a:r>
-              <a:rPr lang="en-US" dirty="0" sz="2200">
+              <a:rPr lang="en-US" dirty="0" sz="1600">
                 <a:solidFill>
                   <a:srgbClr val="FFFFFF"/>
                 </a:solidFill>
@@ -5155,7 +5155,7 @@
           </a:p>
           <a:p>
             <a:r>
-              <a:rPr lang="en-US" dirty="0" sz="2200">
+              <a:rPr lang="en-US" dirty="0" sz="1600">
                 <a:solidFill>
                   <a:srgbClr val="FFFFFF"/>
                 </a:solidFill>
@@ -5165,7 +5165,7 @@
           </a:p>
           <a:p>
             <a:r>
-              <a:rPr lang="en-US" dirty="0" sz="2200">
+              <a:rPr lang="en-US" dirty="0" sz="1600">
                 <a:solidFill>
                   <a:srgbClr val="FFFFFF"/>
                 </a:solidFill>
@@ -5175,7 +5175,7 @@
           </a:p>
           <a:p>
             <a:r>
-              <a:rPr lang="en-US" dirty="0" sz="2200">
+              <a:rPr lang="en-US" dirty="0" sz="1600">
                 <a:solidFill>
                   <a:srgbClr val="FFFFFF"/>
                 </a:solidFill>

</xml_diff>